<commit_message>
Added missing refer to Joe
</commit_message>
<xml_diff>
--- a/FINAL-CANDIDATE JAN292026 CISA Secure by Design Software Acquisition Guide (.pptx
+++ b/FINAL-CANDIDATE JAN292026 CISA Secure by Design Software Acquisition Guide (.pptx
@@ -363,7 +363,7 @@
             <a:fld id="{B61BEF0D-F0BB-DE4B-95CE-6DB70DBA9567}" type="datetimeFigureOut">
               <a:rPr lang="en-US" dirty="0"/>
               <a:pPr/>
-              <a:t>1/27/2026</a:t>
+              <a:t>1/31/2026</a:t>
             </a:fld>
             <a:endParaRPr lang="en-US" dirty="0"/>
           </a:p>
@@ -776,7 +776,7 @@
             <a:fld id="{B61BEF0D-F0BB-DE4B-95CE-6DB70DBA9567}" type="datetimeFigureOut">
               <a:rPr lang="en-US" dirty="0"/>
               <a:pPr/>
-              <a:t>1/27/2026</a:t>
+              <a:t>1/31/2026</a:t>
             </a:fld>
             <a:endParaRPr lang="en-US" dirty="0"/>
           </a:p>
@@ -1051,7 +1051,7 @@
             <a:fld id="{B61BEF0D-F0BB-DE4B-95CE-6DB70DBA9567}" type="datetimeFigureOut">
               <a:rPr lang="en-US" dirty="0"/>
               <a:pPr/>
-              <a:t>1/27/2026</a:t>
+              <a:t>1/31/2026</a:t>
             </a:fld>
             <a:endParaRPr lang="en-US" dirty="0"/>
           </a:p>
@@ -1616,7 +1616,7 @@
             <a:fld id="{B61BEF0D-F0BB-DE4B-95CE-6DB70DBA9567}" type="datetimeFigureOut">
               <a:rPr lang="en-US" dirty="0"/>
               <a:pPr/>
-              <a:t>1/27/2026</a:t>
+              <a:t>1/31/2026</a:t>
             </a:fld>
             <a:endParaRPr lang="en-US" dirty="0"/>
           </a:p>
@@ -1891,7 +1891,7 @@
             <a:fld id="{B61BEF0D-F0BB-DE4B-95CE-6DB70DBA9567}" type="datetimeFigureOut">
               <a:rPr lang="en-US" dirty="0"/>
               <a:pPr/>
-              <a:t>1/27/2026</a:t>
+              <a:t>1/31/2026</a:t>
             </a:fld>
             <a:endParaRPr lang="en-US" dirty="0"/>
           </a:p>
@@ -2450,7 +2450,7 @@
             <a:fld id="{B61BEF0D-F0BB-DE4B-95CE-6DB70DBA9567}" type="datetimeFigureOut">
               <a:rPr lang="en-US" dirty="0"/>
               <a:pPr/>
-              <a:t>1/27/2026</a:t>
+              <a:t>1/31/2026</a:t>
             </a:fld>
             <a:endParaRPr lang="en-US" dirty="0"/>
           </a:p>
@@ -2774,7 +2774,7 @@
             <a:fld id="{B61BEF0D-F0BB-DE4B-95CE-6DB70DBA9567}" type="datetimeFigureOut">
               <a:rPr lang="en-US" dirty="0"/>
               <a:pPr/>
-              <a:t>1/27/2026</a:t>
+              <a:t>1/31/2026</a:t>
             </a:fld>
             <a:endParaRPr lang="en-US" dirty="0"/>
           </a:p>
@@ -2948,7 +2948,7 @@
             <a:fld id="{B61BEF0D-F0BB-DE4B-95CE-6DB70DBA9567}" type="datetimeFigureOut">
               <a:rPr lang="en-US" dirty="0"/>
               <a:pPr/>
-              <a:t>1/27/2026</a:t>
+              <a:t>1/31/2026</a:t>
             </a:fld>
             <a:endParaRPr lang="en-US" dirty="0"/>
           </a:p>
@@ -3183,7 +3183,7 @@
             <a:fld id="{B61BEF0D-F0BB-DE4B-95CE-6DB70DBA9567}" type="datetimeFigureOut">
               <a:rPr lang="en-US" dirty="0"/>
               <a:pPr/>
-              <a:t>1/27/2026</a:t>
+              <a:t>1/31/2026</a:t>
             </a:fld>
             <a:endParaRPr lang="en-US" dirty="0"/>
           </a:p>
@@ -3380,7 +3380,7 @@
             <a:fld id="{B61BEF0D-F0BB-DE4B-95CE-6DB70DBA9567}" type="datetimeFigureOut">
               <a:rPr lang="en-US" dirty="0"/>
               <a:pPr/>
-              <a:t>1/27/2026</a:t>
+              <a:t>1/31/2026</a:t>
             </a:fld>
             <a:endParaRPr lang="en-US" dirty="0"/>
           </a:p>
@@ -3653,7 +3653,7 @@
             <a:fld id="{B61BEF0D-F0BB-DE4B-95CE-6DB70DBA9567}" type="datetimeFigureOut">
               <a:rPr lang="en-US" dirty="0"/>
               <a:pPr/>
-              <a:t>1/27/2026</a:t>
+              <a:t>1/31/2026</a:t>
             </a:fld>
             <a:endParaRPr lang="en-US" dirty="0"/>
           </a:p>
@@ -3916,7 +3916,7 @@
             <a:fld id="{B61BEF0D-F0BB-DE4B-95CE-6DB70DBA9567}" type="datetimeFigureOut">
               <a:rPr lang="en-US" dirty="0"/>
               <a:pPr/>
-              <a:t>1/27/2026</a:t>
+              <a:t>1/31/2026</a:t>
             </a:fld>
             <a:endParaRPr lang="en-US" dirty="0"/>
           </a:p>
@@ -4287,7 +4287,7 @@
             <a:fld id="{B61BEF0D-F0BB-DE4B-95CE-6DB70DBA9567}" type="datetimeFigureOut">
               <a:rPr lang="en-US" dirty="0"/>
               <a:pPr/>
-              <a:t>1/27/2026</a:t>
+              <a:t>1/31/2026</a:t>
             </a:fld>
             <a:endParaRPr lang="en-US" dirty="0"/>
           </a:p>
@@ -4432,7 +4432,7 @@
             <a:fld id="{B61BEF0D-F0BB-DE4B-95CE-6DB70DBA9567}" type="datetimeFigureOut">
               <a:rPr lang="en-US" dirty="0"/>
               <a:pPr/>
-              <a:t>1/27/2026</a:t>
+              <a:t>1/31/2026</a:t>
             </a:fld>
             <a:endParaRPr lang="en-US" dirty="0"/>
           </a:p>
@@ -4554,7 +4554,7 @@
             <a:fld id="{B61BEF0D-F0BB-DE4B-95CE-6DB70DBA9567}" type="datetimeFigureOut">
               <a:rPr lang="en-US" dirty="0"/>
               <a:pPr/>
-              <a:t>1/27/2026</a:t>
+              <a:t>1/31/2026</a:t>
             </a:fld>
             <a:endParaRPr lang="en-US" dirty="0"/>
           </a:p>
@@ -4836,7 +4836,7 @@
             <a:fld id="{B61BEF0D-F0BB-DE4B-95CE-6DB70DBA9567}" type="datetimeFigureOut">
               <a:rPr lang="en-US" dirty="0"/>
               <a:pPr/>
-              <a:t>1/27/2026</a:t>
+              <a:t>1/31/2026</a:t>
             </a:fld>
             <a:endParaRPr lang="en-US" dirty="0"/>
           </a:p>
@@ -5157,7 +5157,7 @@
             <a:fld id="{B61BEF0D-F0BB-DE4B-95CE-6DB70DBA9567}" type="datetimeFigureOut">
               <a:rPr lang="en-US" dirty="0"/>
               <a:pPr/>
-              <a:t>1/27/2026</a:t>
+              <a:t>1/31/2026</a:t>
             </a:fld>
             <a:endParaRPr lang="en-US" dirty="0"/>
           </a:p>
@@ -5367,7 +5367,7 @@
             <a:fld id="{B61BEF0D-F0BB-DE4B-95CE-6DB70DBA9567}" type="datetimeFigureOut">
               <a:rPr lang="en-US" dirty="0"/>
               <a:pPr/>
-              <a:t>1/27/2026</a:t>
+              <a:t>1/31/2026</a:t>
             </a:fld>
             <a:endParaRPr lang="en-US" dirty="0"/>
           </a:p>
@@ -6781,7 +6781,9 @@
           </a:xfrm>
         </p:spPr>
         <p:txBody>
-          <a:bodyPr/>
+          <a:bodyPr>
+            <a:normAutofit fontScale="92500" lnSpcReduction="20000"/>
+          </a:bodyPr>
           <a:lstStyle/>
           <a:p>
             <a:r>
@@ -6821,6 +6823,22 @@
             <a:r>
               <a:rPr lang="en-US" dirty="0"/>
               <a:t>Led and facilitated by CISA personnel over two years</a:t>
+            </a:r>
+          </a:p>
+          <a:p>
+            <a:r>
+              <a:rPr lang="en-US" dirty="0"/>
+              <a:t>Visionary leadership provided by an expert with decades of experience in software assurance, Joe Jarzombek, </a:t>
+            </a:r>
+            <a:r>
+              <a:rPr lang="en-US" dirty="0">
+                <a:hlinkClick r:id="rId3"/>
+              </a:rPr>
+              <a:t>https://copilot.microsoft.com/shares/QLhY366t3XSbYmfegpXEa</a:t>
+            </a:r>
+            <a:r>
+              <a:rPr lang="en-US" dirty="0"/>
+              <a:t> </a:t>
             </a:r>
           </a:p>
         </p:txBody>
@@ -6840,7 +6858,7 @@
           <p:nvPr/>
         </p:nvPicPr>
         <p:blipFill>
-          <a:blip r:embed="rId3"/>
+          <a:blip r:embed="rId4"/>
           <a:stretch>
             <a:fillRect/>
           </a:stretch>
@@ -6870,7 +6888,7 @@
           <p:nvPr/>
         </p:nvPicPr>
         <p:blipFill>
-          <a:blip r:embed="rId4"/>
+          <a:blip r:embed="rId5"/>
           <a:stretch>
             <a:fillRect/>
           </a:stretch>

</xml_diff>